<commit_message>
Update DAG 8 March
</commit_message>
<xml_diff>
--- a/figures/ch7/DAG.pptx
+++ b/figures/ch7/DAG.pptx
@@ -3781,10 +3781,10 @@
       </p:grpSpPr>
       <p:cxnSp>
         <p:nvCxnSpPr>
-          <p:cNvPr id="422" name="Straight Arrow Connector 421">
-            <a:extLst>
-              <a:ext uri="{FF2B5EF4-FFF2-40B4-BE49-F238E27FC236}">
-                <a16:creationId xmlns:a16="http://schemas.microsoft.com/office/drawing/2014/main" id="{13130AB1-3C42-203D-CFA2-58C804A9C26D}"/>
+          <p:cNvPr id="61" name="Straight Arrow Connector 60">
+            <a:extLst>
+              <a:ext uri="{FF2B5EF4-FFF2-40B4-BE49-F238E27FC236}">
+                <a16:creationId xmlns:a16="http://schemas.microsoft.com/office/drawing/2014/main" id="{A9C1D6EF-3050-0CDF-3FC3-B7E8C169A250}"/>
               </a:ext>
             </a:extLst>
           </p:cNvPr>
@@ -3795,8 +3795,8 @@
         </p:nvCxnSpPr>
         <p:spPr>
           <a:xfrm flipH="1">
-            <a:off x="3923310" y="2040469"/>
-            <a:ext cx="4098" cy="1223037"/>
+            <a:off x="3500714" y="3814435"/>
+            <a:ext cx="278094" cy="657041"/>
           </a:xfrm>
           <a:prstGeom prst="straightConnector1">
             <a:avLst/>
@@ -3822,10 +3822,10 @@
       </p:cxnSp>
       <p:cxnSp>
         <p:nvCxnSpPr>
-          <p:cNvPr id="61" name="Straight Arrow Connector 60">
-            <a:extLst>
-              <a:ext uri="{FF2B5EF4-FFF2-40B4-BE49-F238E27FC236}">
-                <a16:creationId xmlns:a16="http://schemas.microsoft.com/office/drawing/2014/main" id="{A9C1D6EF-3050-0CDF-3FC3-B7E8C169A250}"/>
+          <p:cNvPr id="59" name="Straight Arrow Connector 58">
+            <a:extLst>
+              <a:ext uri="{FF2B5EF4-FFF2-40B4-BE49-F238E27FC236}">
+                <a16:creationId xmlns:a16="http://schemas.microsoft.com/office/drawing/2014/main" id="{8DB5F2A5-F3A2-8778-6E07-C63CED55691A}"/>
               </a:ext>
             </a:extLst>
           </p:cNvPr>
@@ -3835,9 +3835,91 @@
           <p:nvPr/>
         </p:nvCxnSpPr>
         <p:spPr>
+          <a:xfrm>
+            <a:off x="2371013" y="3809419"/>
+            <a:ext cx="413264" cy="667808"/>
+          </a:xfrm>
+          <a:prstGeom prst="straightConnector1">
+            <a:avLst/>
+          </a:prstGeom>
+          <a:ln>
+            <a:tailEnd type="triangle"/>
+          </a:ln>
+        </p:spPr>
+        <p:style>
+          <a:lnRef idx="2">
+            <a:schemeClr val="accent1"/>
+          </a:lnRef>
+          <a:fillRef idx="0">
+            <a:schemeClr val="accent1"/>
+          </a:fillRef>
+          <a:effectRef idx="1">
+            <a:schemeClr val="accent1"/>
+          </a:effectRef>
+          <a:fontRef idx="minor">
+            <a:schemeClr val="tx1"/>
+          </a:fontRef>
+        </p:style>
+      </p:cxnSp>
+      <p:cxnSp>
+        <p:nvCxnSpPr>
+          <p:cNvPr id="84" name="Straight Arrow Connector 83">
+            <a:extLst>
+              <a:ext uri="{FF2B5EF4-FFF2-40B4-BE49-F238E27FC236}">
+                <a16:creationId xmlns:a16="http://schemas.microsoft.com/office/drawing/2014/main" id="{8A031F7C-B0AE-12B4-A418-4EBC2E181756}"/>
+              </a:ext>
+            </a:extLst>
+          </p:cNvPr>
+          <p:cNvCxnSpPr>
+            <a:cxnSpLocks/>
+          </p:cNvCxnSpPr>
+          <p:nvPr/>
+        </p:nvCxnSpPr>
+        <p:spPr>
+          <a:xfrm flipV="1">
+            <a:off x="5582431" y="2488919"/>
+            <a:ext cx="433" cy="254779"/>
+          </a:xfrm>
+          <a:prstGeom prst="straightConnector1">
+            <a:avLst/>
+          </a:prstGeom>
+          <a:ln>
+            <a:tailEnd type="triangle"/>
+          </a:ln>
+        </p:spPr>
+        <p:style>
+          <a:lnRef idx="2">
+            <a:schemeClr val="accent1"/>
+          </a:lnRef>
+          <a:fillRef idx="0">
+            <a:schemeClr val="accent1"/>
+          </a:fillRef>
+          <a:effectRef idx="1">
+            <a:schemeClr val="accent1"/>
+          </a:effectRef>
+          <a:fontRef idx="minor">
+            <a:schemeClr val="tx1"/>
+          </a:fontRef>
+        </p:style>
+      </p:cxnSp>
+      <p:cxnSp>
+        <p:nvCxnSpPr>
+          <p:cNvPr id="422" name="Straight Arrow Connector 421">
+            <a:extLst>
+              <a:ext uri="{FF2B5EF4-FFF2-40B4-BE49-F238E27FC236}">
+                <a16:creationId xmlns:a16="http://schemas.microsoft.com/office/drawing/2014/main" id="{13130AB1-3C42-203D-CFA2-58C804A9C26D}"/>
+              </a:ext>
+            </a:extLst>
+          </p:cNvPr>
+          <p:cNvCxnSpPr>
+            <a:cxnSpLocks/>
+          </p:cNvCxnSpPr>
+          <p:nvPr/>
+        </p:nvCxnSpPr>
+        <p:spPr>
           <a:xfrm flipH="1">
-            <a:off x="3500714" y="3825937"/>
-            <a:ext cx="278094" cy="657041"/>
+            <a:off x="3923310" y="2040469"/>
+            <a:ext cx="4098" cy="1223037"/>
           </a:xfrm>
           <a:prstGeom prst="straightConnector1">
             <a:avLst/>
@@ -3924,7 +4006,9 @@
             <a:avLst/>
           </a:prstGeom>
           <a:solidFill>
-            <a:schemeClr val="bg2"/>
+            <a:schemeClr val="bg1">
+              <a:lumMod val="95000"/>
+            </a:schemeClr>
           </a:solidFill>
         </p:spPr>
         <p:style>
@@ -4141,7 +4225,7 @@
           <a:prstGeom prst="straightConnector1">
             <a:avLst/>
           </a:prstGeom>
-          <a:ln>
+          <a:ln w="57150">
             <a:tailEnd type="triangle"/>
           </a:ln>
         </p:spPr>
@@ -4259,7 +4343,7 @@
         </p:nvCxnSpPr>
         <p:spPr>
           <a:xfrm flipH="1">
-            <a:off x="4057342" y="3917900"/>
+            <a:off x="4040089" y="3935153"/>
             <a:ext cx="1024024" cy="554311"/>
           </a:xfrm>
           <a:prstGeom prst="straightConnector1">
@@ -4307,7 +4391,7 @@
           <a:prstGeom prst="straightConnector1">
             <a:avLst/>
           </a:prstGeom>
-          <a:ln>
+          <a:ln w="57150">
             <a:tailEnd type="triangle"/>
           </a:ln>
         </p:spPr>
@@ -4348,7 +4432,7 @@
           <a:prstGeom prst="straightConnector1">
             <a:avLst/>
           </a:prstGeom>
-          <a:ln>
+          <a:ln w="57150">
             <a:tailEnd type="triangle"/>
           </a:ln>
         </p:spPr>
@@ -4547,7 +4631,7 @@
               <a:lumOff val="80000"/>
             </a:schemeClr>
           </a:solidFill>
-          <a:ln w="28575"/>
+          <a:ln w="19050"/>
         </p:spPr>
         <p:style>
           <a:lnRef idx="2">
@@ -4604,7 +4688,7 @@
             <a:avLst/>
           </a:prstGeom>
           <a:solidFill>
-            <a:schemeClr val="accent4"/>
+            <a:schemeClr val="accent1"/>
           </a:solidFill>
           <a:ln w="28575"/>
         </p:spPr>
@@ -4785,7 +4869,7 @@
             <a:avLst/>
           </a:prstGeom>
           <a:solidFill>
-            <a:schemeClr val="accent2">
+            <a:schemeClr val="accent5">
               <a:lumMod val="20000"/>
               <a:lumOff val="80000"/>
             </a:schemeClr>
@@ -5130,47 +5214,6 @@
           </a:p>
         </p:txBody>
       </p:sp>
-      <p:cxnSp>
-        <p:nvCxnSpPr>
-          <p:cNvPr id="59" name="Straight Arrow Connector 58">
-            <a:extLst>
-              <a:ext uri="{FF2B5EF4-FFF2-40B4-BE49-F238E27FC236}">
-                <a16:creationId xmlns:a16="http://schemas.microsoft.com/office/drawing/2014/main" id="{8DB5F2A5-F3A2-8778-6E07-C63CED55691A}"/>
-              </a:ext>
-            </a:extLst>
-          </p:cNvPr>
-          <p:cNvCxnSpPr>
-            <a:cxnSpLocks/>
-          </p:cNvCxnSpPr>
-          <p:nvPr/>
-        </p:nvCxnSpPr>
-        <p:spPr>
-          <a:xfrm>
-            <a:off x="2371013" y="3815170"/>
-            <a:ext cx="413264" cy="667808"/>
-          </a:xfrm>
-          <a:prstGeom prst="straightConnector1">
-            <a:avLst/>
-          </a:prstGeom>
-          <a:ln>
-            <a:tailEnd type="triangle"/>
-          </a:ln>
-        </p:spPr>
-        <p:style>
-          <a:lnRef idx="2">
-            <a:schemeClr val="accent1"/>
-          </a:lnRef>
-          <a:fillRef idx="0">
-            <a:schemeClr val="accent1"/>
-          </a:fillRef>
-          <a:effectRef idx="1">
-            <a:schemeClr val="accent1"/>
-          </a:effectRef>
-          <a:fontRef idx="minor">
-            <a:schemeClr val="tx1"/>
-          </a:fontRef>
-        </p:style>
-      </p:cxnSp>
       <p:sp>
         <p:nvSpPr>
           <p:cNvPr id="80" name="Rounded Rectangle 79">
@@ -5234,49 +5277,6 @@
       </p:sp>
       <p:cxnSp>
         <p:nvCxnSpPr>
-          <p:cNvPr id="84" name="Straight Arrow Connector 83">
-            <a:extLst>
-              <a:ext uri="{FF2B5EF4-FFF2-40B4-BE49-F238E27FC236}">
-                <a16:creationId xmlns:a16="http://schemas.microsoft.com/office/drawing/2014/main" id="{8A031F7C-B0AE-12B4-A418-4EBC2E181756}"/>
-              </a:ext>
-            </a:extLst>
-          </p:cNvPr>
-          <p:cNvCxnSpPr>
-            <a:cxnSpLocks/>
-            <a:stCxn id="6" idx="0"/>
-            <a:endCxn id="48" idx="2"/>
-          </p:cNvCxnSpPr>
-          <p:nvPr/>
-        </p:nvCxnSpPr>
-        <p:spPr>
-          <a:xfrm flipV="1">
-            <a:off x="5588182" y="2488917"/>
-            <a:ext cx="433" cy="254779"/>
-          </a:xfrm>
-          <a:prstGeom prst="straightConnector1">
-            <a:avLst/>
-          </a:prstGeom>
-          <a:ln>
-            <a:tailEnd type="triangle"/>
-          </a:ln>
-        </p:spPr>
-        <p:style>
-          <a:lnRef idx="2">
-            <a:schemeClr val="accent1"/>
-          </a:lnRef>
-          <a:fillRef idx="0">
-            <a:schemeClr val="accent1"/>
-          </a:fillRef>
-          <a:effectRef idx="1">
-            <a:schemeClr val="accent1"/>
-          </a:effectRef>
-          <a:fontRef idx="minor">
-            <a:schemeClr val="tx1"/>
-          </a:fontRef>
-        </p:style>
-      </p:cxnSp>
-      <p:cxnSp>
-        <p:nvCxnSpPr>
           <p:cNvPr id="107" name="Straight Arrow Connector 106">
             <a:extLst>
               <a:ext uri="{FF2B5EF4-FFF2-40B4-BE49-F238E27FC236}">
@@ -5670,14 +5670,12 @@
           </p:cNvPr>
           <p:cNvCxnSpPr>
             <a:cxnSpLocks/>
-            <a:stCxn id="6" idx="2"/>
-            <a:endCxn id="323" idx="0"/>
           </p:cNvCxnSpPr>
           <p:nvPr/>
         </p:nvCxnSpPr>
         <p:spPr>
           <a:xfrm>
-            <a:off x="5588182" y="3304271"/>
+            <a:off x="5582926" y="3300008"/>
             <a:ext cx="0" cy="291038"/>
           </a:xfrm>
           <a:prstGeom prst="straightConnector1">

</xml_diff>